<commit_message>
fix(v2): 릴레이 모듈이 LOW에서 켜짐 — RELAY_ACTIVE_LOW 기본값 true
실측: on 명령에 꺼지고 off에 켜짐 → 이 모듈은 LOW 트리거.
- step2_relay_test · step3_auto_lamp · step4_app_lamp · step5_app_mqtt 기본값 true
- wiring.md · README · parts.md · step2 README · 배선도(SVG/PNG) 라벨을 LOW 트리거로
- 학생용 PPT 릴레이 장(코드·증상 카드)과 교사 노트 갱신

검증: V2 시뮬레이션 20/25/16 통과, 배선 검사 통과, ESP32 컴파일 4개 통과

Co-Authored-By: Claude Fable 5.1 <noreply@anthropic.com>
Claude-Session: https://claude.ai/code/session_013meiHivMhyCpvDxW2U27B7
</commit_message>
<xml_diff>
--- a/iot-mood-lamp/docs/lesson_3h_student.pptx
+++ b/iot-mood-lamp/docs/lesson_3h_student.pptx
@@ -120,26 +120,26 @@
   <p:extLst>
     <p:ext uri="{521415D9-36F7-43E2-AB2F-B90AF26B5E84}">
       <p14:sectionLst xmlns:p14="http://schemas.microsoft.com/office/powerpoint/2010/main">
-        <p14:section name="시작" id="{5ea48ca7-3a5a-eb42-c883-2e18db436735}">
+        <p14:section name="시작" id="{125c6f7e-3f90-2d0e-db3d-6e28c0ab0e1b}">
           <p14:sldIdLst>
             <p14:sldId id="256"/>
           </p14:sldIdLst>
         </p14:section>
-        <p14:section name="소개" id="{4796d09a-8b74-5089-e860-d67fa1642822}">
+        <p14:section name="소개" id="{cafc5e12-192b-0b38-837a-7ad7b4095180}">
           <p14:sldIdLst>
             <p14:sldId id="257"/>
             <p14:sldId id="258"/>
             <p14:sldId id="259"/>
           </p14:sldIdLst>
         </p14:section>
-        <p14:section name="배선" id="{a47db895-9102-fccc-ad82-a9895b927a29}">
+        <p14:section name="배선" id="{8d4d01af-f6d0-f33a-6280-3077a780a1b1}">
           <p14:sldIdLst>
             <p14:sldId id="260"/>
             <p14:sldId id="261"/>
             <p14:sldId id="262"/>
           </p14:sldIdLst>
         </p14:section>
-        <p14:section name="진행" id="{bd1ead31-c3f4-0047-faba-2d79aed1c679}">
+        <p14:section name="진행" id="{74c02b44-eb3a-8f2c-52d0-56a309a0952f}">
           <p14:sldIdLst>
             <p14:sldId id="263"/>
             <p14:sldId id="264"/>
@@ -148,7 +148,7 @@
             <p14:sldId id="267"/>
           </p14:sldIdLst>
         </p14:section>
-        <p14:section name="도움" id="{0f88e225-a2a7-cfa2-a336-fb65f905dee8}">
+        <p14:section name="도움" id="{093f4f5a-5a2f-2f36-c6d1-54c501e40098}">
           <p14:sldIdLst>
             <p14:sldId id="268"/>
             <p14:sldId id="269"/>
@@ -654,7 +654,7 @@
             <a:r>
               <a:rPr lang="en-US" dirty="0"/>
               <a:t>[교사 노트] V2 릴레이 코드 배경
-- KY-019형은 HIGH 트리거 → RELAY_ACTIVE_LOW = false. LOW에서 켜지는 모듈이면 true.
+- 이번 모듈은 실측 결과 LOW에서 켜지는 종류라 RELAY_ACTIVE_LOW = true 가 기본값. HIGH에서 켜지는 모듈이면 false. 학생이 '1에서 꺼진다'고 하면 이 값을 반대로.
 - 부팅 순간 전구가 깜빡이지 않게 pinMode보다 먼저 '꺼짐' 값을 써 둔다. 리셋 버튼 테스트는 이것을 확인하는 절차.
 - 220V 없이 릴레이만 꽂고 테스트한다. '딸깍' 소리 + 모듈 LED로 충분히 확인된다.
 - 시리얼 명령: 1(켜기) · 0(끄기) · t(토글) · blink(3번). on/off도 된다.
@@ -3677,7 +3677,7 @@
                 <a:ea typeface="JetBrains Mono" pitchFamily="34" charset="-122"/>
                 <a:cs typeface="JetBrains Mono" pitchFamily="34" charset="-120"/>
               </a:rPr>
-              <a:t>const bool RELAY_ACTIVE_LOW = false; // KY-019형 = HIGH에서 켜짐</a:t>
+              <a:t>const bool RELAY_ACTIVE_LOW = true;  // 이 모듈은 LOW에서 켜짐</a:t>
             </a:r>
             <a:endParaRPr lang="en-US" sz="1100" dirty="0"/>
           </a:p>
@@ -4549,7 +4549,7 @@
                   <a:schemeClr val="tx2"/>
                 </a:solidFill>
               </a:rPr>
-              <a:t>1에서 꺼지고 0에서 켜지면 RELAY_ACTIVE_LOW = true 로 바꿔 업로드</a:t>
+              <a:t>1에서 꺼지고 0에서 켜지면 RELAY_ACTIVE_LOW 를 반대로(true↔false) 바꿔 업로드</a:t>
             </a:r>
             <a:endParaRPr lang="en-US" sz="1050" dirty="0"/>
           </a:p>

</xml_diff>